<commit_message>
Update final project materials
</commit_message>
<xml_diff>
--- a/coastal-temperature-prediction.pptx
+++ b/coastal-temperature-prediction.pptx
@@ -3450,6 +3450,42 @@
           </a:p>
         </p:txBody>
       </p:sp>
+      <p:pic>
+        <p:nvPicPr>
+          <p:cNvPr id="20" name="图片 19">
+            <a:extLst>
+              <a:ext uri="{FF2B5EF4-FFF2-40B4-BE49-F238E27FC236}">
+                <a16:creationId xmlns:a16="http://schemas.microsoft.com/office/drawing/2014/main" id="{2EDBAFC8-EF05-4617-0175-AAE35DF8E4F5}"/>
+              </a:ext>
+            </a:extLst>
+          </p:cNvPr>
+          <p:cNvPicPr>
+            <a:picLocks/>
+          </p:cNvPicPr>
+          <p:nvPr/>
+        </p:nvPicPr>
+        <p:blipFill>
+          <a:blip r:embed="rId4">
+            <a:extLst>
+              <a:ext uri="{28A0092B-C50C-407E-A947-70E740481C1C}">
+                <a14:useLocalDpi xmlns:a14="http://schemas.microsoft.com/office/drawing/2010/main" val="0"/>
+              </a:ext>
+            </a:extLst>
+          </a:blip>
+          <a:stretch>
+            <a:fillRect/>
+          </a:stretch>
+        </p:blipFill>
+        <p:spPr>
+          <a:xfrm>
+            <a:off x="8128000" y="1422400"/>
+            <a:ext cx="3352800" cy="3911600"/>
+          </a:xfrm>
+          <a:prstGeom prst="rect">
+            <a:avLst/>
+          </a:prstGeom>
+        </p:spPr>
+      </p:pic>
     </p:spTree>
     <p:extLst>
       <p:ext uri="{BB962C8B-B14F-4D97-AF65-F5344CB8AC3E}">
@@ -3460,7 +3496,7 @@
   <p:clrMapOvr>
     <a:masterClrMapping/>
   </p:clrMapOvr>
-  <p:transition spd="med" advClick="1">
+  <p:transition spd="med">
     <p:fade/>
   </p:transition>
 </p:sld>
@@ -4614,7 +4650,7 @@
   <p:clrMapOvr>
     <a:masterClrMapping/>
   </p:clrMapOvr>
-  <p:transition spd="med" advClick="1">
+  <p:transition spd="med">
     <p:fade/>
   </p:transition>
 </p:sld>
@@ -5487,7 +5523,7 @@
   <p:clrMapOvr>
     <a:masterClrMapping/>
   </p:clrMapOvr>
-  <p:transition spd="med" advClick="1">
+  <p:transition spd="med">
     <p:fade/>
   </p:transition>
 </p:sld>
@@ -6267,7 +6303,7 @@
   <p:clrMapOvr>
     <a:masterClrMapping/>
   </p:clrMapOvr>
-  <p:transition spd="med" advClick="1">
+  <p:transition spd="med">
     <p:fade/>
   </p:transition>
 </p:sld>
@@ -7479,7 +7515,7 @@
   <p:clrMapOvr>
     <a:masterClrMapping/>
   </p:clrMapOvr>
-  <p:transition spd="med" advClick="1">
+  <p:transition spd="med">
     <p:fade/>
   </p:transition>
 </p:sld>
@@ -9022,7 +9058,7 @@
   <p:clrMapOvr>
     <a:masterClrMapping/>
   </p:clrMapOvr>
-  <p:transition spd="med" advClick="1">
+  <p:transition spd="med">
     <p:fade/>
   </p:transition>
 </p:sld>
@@ -10520,7 +10556,7 @@
   <p:clrMapOvr>
     <a:masterClrMapping/>
   </p:clrMapOvr>
-  <p:transition spd="med" advClick="1">
+  <p:transition spd="med">
     <p:fade/>
   </p:transition>
 </p:sld>
@@ -11419,6 +11455,42 @@
           </a:p>
         </p:txBody>
       </p:sp>
+      <p:pic>
+        <p:nvPicPr>
+          <p:cNvPr id="20" name="图片 19">
+            <a:extLst>
+              <a:ext uri="{FF2B5EF4-FFF2-40B4-BE49-F238E27FC236}">
+                <a16:creationId xmlns:a16="http://schemas.microsoft.com/office/drawing/2014/main" id="{9872BFF2-6F66-5937-4C98-74AC1BF324F9}"/>
+              </a:ext>
+            </a:extLst>
+          </p:cNvPr>
+          <p:cNvPicPr>
+            <a:picLocks/>
+          </p:cNvPicPr>
+          <p:nvPr/>
+        </p:nvPicPr>
+        <p:blipFill>
+          <a:blip r:embed="rId4">
+            <a:extLst>
+              <a:ext uri="{28A0092B-C50C-407E-A947-70E740481C1C}">
+                <a14:useLocalDpi xmlns:a14="http://schemas.microsoft.com/office/drawing/2010/main" val="0"/>
+              </a:ext>
+            </a:extLst>
+          </a:blip>
+          <a:stretch>
+            <a:fillRect/>
+          </a:stretch>
+        </p:blipFill>
+        <p:spPr>
+          <a:xfrm>
+            <a:off x="7543800" y="1473200"/>
+            <a:ext cx="3784600" cy="3784600"/>
+          </a:xfrm>
+          <a:prstGeom prst="rect">
+            <a:avLst/>
+          </a:prstGeom>
+        </p:spPr>
+      </p:pic>
     </p:spTree>
     <p:extLst>
       <p:ext uri="{BB962C8B-B14F-4D97-AF65-F5344CB8AC3E}">
@@ -11429,7 +11501,7 @@
   <p:clrMapOvr>
     <a:masterClrMapping/>
   </p:clrMapOvr>
-  <p:transition spd="med" advClick="1">
+  <p:transition spd="med">
     <p:fade/>
   </p:transition>
 </p:sld>
@@ -12393,6 +12465,42 @@
           </a:p>
         </p:txBody>
       </p:sp>
+      <p:pic>
+        <p:nvPicPr>
+          <p:cNvPr id="21" name="图片 20">
+            <a:extLst>
+              <a:ext uri="{FF2B5EF4-FFF2-40B4-BE49-F238E27FC236}">
+                <a16:creationId xmlns:a16="http://schemas.microsoft.com/office/drawing/2014/main" id="{4F7C6249-895E-D498-4DDE-4C751B80F4F7}"/>
+              </a:ext>
+            </a:extLst>
+          </p:cNvPr>
+          <p:cNvPicPr>
+            <a:picLocks/>
+          </p:cNvPicPr>
+          <p:nvPr/>
+        </p:nvPicPr>
+        <p:blipFill>
+          <a:blip r:embed="rId4">
+            <a:extLst>
+              <a:ext uri="{28A0092B-C50C-407E-A947-70E740481C1C}">
+                <a14:useLocalDpi xmlns:a14="http://schemas.microsoft.com/office/drawing/2010/main" val="0"/>
+              </a:ext>
+            </a:extLst>
+          </a:blip>
+          <a:stretch>
+            <a:fillRect/>
+          </a:stretch>
+        </p:blipFill>
+        <p:spPr>
+          <a:xfrm>
+            <a:off x="7543800" y="1473200"/>
+            <a:ext cx="3784600" cy="3784600"/>
+          </a:xfrm>
+          <a:prstGeom prst="rect">
+            <a:avLst/>
+          </a:prstGeom>
+        </p:spPr>
+      </p:pic>
     </p:spTree>
     <p:extLst>
       <p:ext uri="{BB962C8B-B14F-4D97-AF65-F5344CB8AC3E}">
@@ -12403,7 +12511,7 @@
   <p:clrMapOvr>
     <a:masterClrMapping/>
   </p:clrMapOvr>
-  <p:transition spd="med" advClick="1">
+  <p:transition spd="med">
     <p:fade/>
   </p:transition>
 </p:sld>

</xml_diff>